<commit_message>
Document the backend fallback and per-model costs; refresh both decks
Drafts: both now describe how the backend is chosen, what happens when a
model runs on the GPU and produces nothing usable, and why the cost table
is kept per model. The energy-aware table asserted "GPU unavailable" with
no account of how that is detected.

Decks: the energy deck's GPU-or-CPU slide is rewritten for the v2.5
behaviour, with the Bonsai case and the CPU tier costs. The main talk
deck carried the superseded paper title and a text box that overflowed
into the one below it on slide 7; both are fixed.

Co-Authored-By: Claude Opus 5 (1M context) <noreply@anthropic.com>
</commit_message>
<xml_diff>
--- a/muKV_energy_rl_talk.pptx
+++ b/muKV_energy_rl_talk.pptx
@@ -10741,7 +10741,7 @@
                 </a:solidFill>
                 <a:latin typeface="Arial"/>
               </a:rPr>
-              <a:t>The GPU whenever it exists; the CPU is the fallback</a:t>
+              <a:t>The GPU whenever it works; the CPU is the fallback</a:t>
             </a:r>
           </a:p>
         </p:txBody>
@@ -10839,7 +10839,7 @@
         </p:nvGraphicFramePr>
         <p:xfrm>
           <a:off x="548640" y="1645920"/>
-          <a:ext cx="6766560" cy="2377440"/>
+          <a:ext cx="6309360" cy="2103120"/>
         </p:xfrm>
         <a:graphic>
           <a:graphicData uri="http://schemas.openxmlformats.org/drawingml/2006/table">
@@ -10848,18 +10848,18 @@
                 <a:tableStyleId>{5C22544A-7EE6-4342-B048-85BDC9FD1C3A}</a:tableStyleId>
               </a:tblPr>
               <a:tblGrid>
-                <a:gridCol w="3657600"/>
+                <a:gridCol w="3291840"/>
                 <a:gridCol w="1554480"/>
-                <a:gridCol w="1554480"/>
+                <a:gridCol w="1463040"/>
               </a:tblGrid>
-              <a:tr h="475488">
+              <a:tr h="420624">
                 <a:tc>
                   <a:txBody>
                     <a:bodyPr wrap="square"/>
                     <a:lstStyle/>
                     <a:p>
                       <a:r>
-                        <a:rPr sz="1500" b="1">
+                        <a:rPr sz="1400" b="1">
                           <a:solidFill>
                             <a:srgbClr val="0C1116"/>
                           </a:solidFill>
@@ -10881,7 +10881,7 @@
                     <a:lstStyle/>
                     <a:p>
                       <a:r>
-                        <a:rPr sz="1500" b="1">
+                        <a:rPr sz="1400" b="1">
                           <a:solidFill>
                             <a:srgbClr val="0C1116"/>
                           </a:solidFill>
@@ -10903,7 +10903,7 @@
                     <a:lstStyle/>
                     <a:p>
                       <a:r>
-                        <a:rPr sz="1500" b="1">
+                        <a:rPr sz="1400" b="1">
                           <a:solidFill>
                             <a:srgbClr val="0C1116"/>
                           </a:solidFill>
@@ -10920,14 +10920,14 @@
                   </a:tcPr>
                 </a:tc>
               </a:tr>
-              <a:tr h="475488">
+              <a:tr h="420624">
                 <a:tc>
                   <a:txBody>
                     <a:bodyPr wrap="square"/>
                     <a:lstStyle/>
                     <a:p>
                       <a:r>
-                        <a:rPr sz="1500" b="0">
+                        <a:rPr sz="1400" b="0">
                           <a:solidFill>
                             <a:srgbClr val="38424E"/>
                           </a:solidFill>
@@ -10949,7 +10949,7 @@
                     <a:lstStyle/>
                     <a:p>
                       <a:r>
-                        <a:rPr sz="1500" b="0">
+                        <a:rPr sz="1400" b="0">
                           <a:solidFill>
                             <a:srgbClr val="38424E"/>
                           </a:solidFill>
@@ -10971,7 +10971,7 @@
                     <a:lstStyle/>
                     <a:p>
                       <a:r>
-                        <a:rPr sz="1500" b="0">
+                        <a:rPr sz="1400" b="0">
                           <a:solidFill>
                             <a:srgbClr val="38424E"/>
                           </a:solidFill>
@@ -10988,14 +10988,14 @@
                   </a:tcPr>
                 </a:tc>
               </a:tr>
-              <a:tr h="475488">
+              <a:tr h="420624">
                 <a:tc>
                   <a:txBody>
                     <a:bodyPr wrap="square"/>
                     <a:lstStyle/>
                     <a:p>
                       <a:r>
-                        <a:rPr sz="1500" b="0">
+                        <a:rPr sz="1400" b="0">
                           <a:solidFill>
                             <a:srgbClr val="38424E"/>
                           </a:solidFill>
@@ -11017,7 +11017,7 @@
                     <a:lstStyle/>
                     <a:p>
                       <a:r>
-                        <a:rPr sz="1500" b="0">
+                        <a:rPr sz="1400" b="0">
                           <a:solidFill>
                             <a:srgbClr val="38424E"/>
                           </a:solidFill>
@@ -11039,7 +11039,7 @@
                     <a:lstStyle/>
                     <a:p>
                       <a:r>
-                        <a:rPr sz="1500" b="0">
+                        <a:rPr sz="1400" b="0">
                           <a:solidFill>
                             <a:srgbClr val="38424E"/>
                           </a:solidFill>
@@ -11056,14 +11056,14 @@
                   </a:tcPr>
                 </a:tc>
               </a:tr>
-              <a:tr h="475488">
+              <a:tr h="420624">
                 <a:tc>
                   <a:txBody>
                     <a:bodyPr wrap="square"/>
                     <a:lstStyle/>
                     <a:p>
                       <a:r>
-                        <a:rPr sz="1500" b="0">
+                        <a:rPr sz="1400" b="0">
                           <a:solidFill>
                             <a:srgbClr val="38424E"/>
                           </a:solidFill>
@@ -11085,7 +11085,7 @@
                     <a:lstStyle/>
                     <a:p>
                       <a:r>
-                        <a:rPr sz="1500" b="0">
+                        <a:rPr sz="1400" b="0">
                           <a:solidFill>
                             <a:srgbClr val="38424E"/>
                           </a:solidFill>
@@ -11107,7 +11107,7 @@
                     <a:lstStyle/>
                     <a:p>
                       <a:r>
-                        <a:rPr sz="1500" b="0">
+                        <a:rPr sz="1400" b="0">
                           <a:solidFill>
                             <a:srgbClr val="38424E"/>
                           </a:solidFill>
@@ -11124,14 +11124,14 @@
                   </a:tcPr>
                 </a:tc>
               </a:tr>
-              <a:tr h="475488">
+              <a:tr h="420624">
                 <a:tc>
                   <a:txBody>
                     <a:bodyPr wrap="square"/>
                     <a:lstStyle/>
                     <a:p>
                       <a:r>
-                        <a:rPr sz="1500" b="1">
+                        <a:rPr sz="1400" b="1">
                           <a:solidFill>
                             <a:srgbClr val="0C1116"/>
                           </a:solidFill>
@@ -11153,7 +11153,7 @@
                     <a:lstStyle/>
                     <a:p>
                       <a:r>
-                        <a:rPr sz="1500" b="1">
+                        <a:rPr sz="1400" b="1">
                           <a:solidFill>
                             <a:srgbClr val="0C1116"/>
                           </a:solidFill>
@@ -11175,7 +11175,7 @@
                     <a:lstStyle/>
                     <a:p>
                       <a:r>
-                        <a:rPr sz="1500" b="1">
+                        <a:rPr sz="1400" b="1">
                           <a:solidFill>
                             <a:srgbClr val="0C1116"/>
                           </a:solidFill>
@@ -11204,107 +11204,8 @@
         </p:nvSpPr>
         <p:spPr>
           <a:xfrm>
-            <a:off x="7680960" y="1645920"/>
-            <a:ext cx="4114800" cy="4114800"/>
-          </a:xfrm>
-          <a:prstGeom prst="rect">
-            <a:avLst/>
-          </a:prstGeom>
-          <a:noFill/>
-        </p:spPr>
-        <p:txBody>
-          <a:bodyPr wrap="square" lIns="36576" rIns="36576">
-            <a:spAutoFit/>
-          </a:bodyPr>
-          <a:lstStyle/>
-          <a:p>
-            <a:pPr>
-              <a:lnSpc>
-                <a:spcPct val="112000"/>
-              </a:lnSpc>
-              <a:spcAft>
-                <a:spcPts val="1000"/>
-              </a:spcAft>
-            </a:pPr>
-            <a:r>
-              <a:rPr sz="1500">
-                <a:solidFill>
-                  <a:srgbClr val="38424E"/>
-                </a:solidFill>
-                <a:latin typeface="Arial"/>
-              </a:rPr>
-              <a:t>•  The cost table holds CPU plans too. They lose to every GPU plan on both energy and time, so the walk never picks them.</a:t>
-            </a:r>
-          </a:p>
-          <a:p>
-            <a:pPr>
-              <a:lnSpc>
-                <a:spcPct val="112000"/>
-              </a:lnSpc>
-              <a:spcAft>
-                <a:spcPts val="1000"/>
-              </a:spcAft>
-            </a:pPr>
-            <a:r>
-              <a:rPr sz="1500">
-                <a:solidFill>
-                  <a:srgbClr val="38424E"/>
-                </a:solidFill>
-                <a:latin typeface="Arial"/>
-              </a:rPr>
-              <a:t>•  The scheduler uses the CPU only when the GPU is unavailable: no Vulkan library, or the caller forced CPU.</a:t>
-            </a:r>
-          </a:p>
-          <a:p>
-            <a:pPr>
-              <a:lnSpc>
-                <a:spcPct val="112000"/>
-              </a:lnSpc>
-              <a:spcAft>
-                <a:spcPts val="1000"/>
-              </a:spcAft>
-            </a:pPr>
-            <a:r>
-              <a:rPr sz="1500">
-                <a:solidFill>
-                  <a:srgbClr val="38424E"/>
-                </a:solidFill>
-                <a:latin typeface="Arial"/>
-              </a:rPr>
-              <a:t>•  A hot phone (battery ≥ 40 °C or DDR ≥ 60 °C) does not switch to the CPU. It removes the 1200 MHz plan without a decode cap.</a:t>
-            </a:r>
-          </a:p>
-          <a:p>
-            <a:pPr>
-              <a:lnSpc>
-                <a:spcPct val="112000"/>
-              </a:lnSpc>
-              <a:spcAft>
-                <a:spcPts val="1000"/>
-              </a:spcAft>
-            </a:pPr>
-            <a:r>
-              <a:rPr sz="1500">
-                <a:solidFill>
-                  <a:srgbClr val="38424E"/>
-                </a:solidFill>
-                <a:latin typeface="Arial"/>
-              </a:rPr>
-              <a:t>•  The CPU clock is never an energy decision. It belongs to the thermal watchdog.</a:t>
-            </a:r>
-          </a:p>
-        </p:txBody>
-      </p:sp>
-      <p:sp>
-        <p:nvSpPr>
-          <p:cNvPr id="8" name="TextBox 7"/>
-          <p:cNvSpPr txBox="1"/>
-          <p:nvPr/>
-        </p:nvSpPr>
-        <p:spPr>
-          <a:xfrm>
-            <a:off x="548640" y="6382512"/>
-            <a:ext cx="10424160" cy="365760"/>
+            <a:off x="548640" y="3931920"/>
+            <a:ext cx="6309360" cy="731520"/>
           </a:xfrm>
           <a:prstGeom prst="rect">
             <a:avLst/>
@@ -11323,13 +11224,494 @@
               </a:lnSpc>
             </a:pPr>
             <a:r>
+              <a:rPr sz="1500" b="0">
+                <a:solidFill>
+                  <a:srgbClr val="38424E"/>
+                </a:solidFill>
+                <a:latin typeface="Arial"/>
+              </a:rPr>
+              <a:t>CPU plans lose on both axes, so the ladder walk never reaches them while the GPU works.</a:t>
+            </a:r>
+          </a:p>
+        </p:txBody>
+      </p:sp>
+      <p:sp>
+        <p:nvSpPr>
+          <p:cNvPr id="8" name="Rounded Rectangle 7"/>
+          <p:cNvSpPr/>
+          <p:nvPr/>
+        </p:nvSpPr>
+        <p:spPr>
+          <a:xfrm>
+            <a:off x="7132320" y="1645920"/>
+            <a:ext cx="4572000" cy="914400"/>
+          </a:xfrm>
+          <a:prstGeom prst="roundRect">
+            <a:avLst>
+              <a:gd name="adj" fmla="val 6000"/>
+            </a:avLst>
+          </a:prstGeom>
+          <a:solidFill>
+            <a:srgbClr val="F4F6F8"/>
+          </a:solidFill>
+          <a:ln w="15875">
+            <a:solidFill>
+              <a:srgbClr val="D9DEE4"/>
+            </a:solidFill>
+          </a:ln>
+          <a:effectLst/>
+        </p:spPr>
+        <p:style>
+          <a:lnRef idx="1">
+            <a:schemeClr val="accent1"/>
+          </a:lnRef>
+          <a:fillRef idx="3">
+            <a:schemeClr val="accent1"/>
+          </a:fillRef>
+          <a:effectRef idx="2">
+            <a:schemeClr val="accent1"/>
+          </a:effectRef>
+          <a:fontRef idx="minor">
+            <a:schemeClr val="lt1"/>
+          </a:fontRef>
+        </p:style>
+        <p:txBody>
+          <a:bodyPr rtlCol="0" anchor="ctr" wrap="square"/>
+          <a:lstStyle/>
+          <a:p>
+            <a:pPr algn="ctr"/>
+            <a:r>
+              <a:rPr sz="1400" b="1">
+                <a:solidFill>
+                  <a:srgbClr val="0C1116"/>
+                </a:solidFill>
+                <a:latin typeface="Arial"/>
+              </a:rPr>
+              <a:t>1  No Vulkan library, or the caller forced CPU</a:t>
+            </a:r>
+          </a:p>
+        </p:txBody>
+      </p:sp>
+      <p:sp>
+        <p:nvSpPr>
+          <p:cNvPr id="9" name="Rounded Rectangle 8"/>
+          <p:cNvSpPr/>
+          <p:nvPr/>
+        </p:nvSpPr>
+        <p:spPr>
+          <a:xfrm>
+            <a:off x="7132320" y="2743200"/>
+            <a:ext cx="4572000" cy="1371600"/>
+          </a:xfrm>
+          <a:prstGeom prst="roundRect">
+            <a:avLst>
+              <a:gd name="adj" fmla="val 6000"/>
+            </a:avLst>
+          </a:prstGeom>
+          <a:solidFill>
+            <a:srgbClr val="FBEDE3"/>
+          </a:solidFill>
+          <a:ln w="15875">
+            <a:solidFill>
+              <a:srgbClr val="C4581A"/>
+            </a:solidFill>
+          </a:ln>
+          <a:effectLst/>
+        </p:spPr>
+        <p:style>
+          <a:lnRef idx="1">
+            <a:schemeClr val="accent1"/>
+          </a:lnRef>
+          <a:fillRef idx="3">
+            <a:schemeClr val="accent1"/>
+          </a:fillRef>
+          <a:effectRef idx="2">
+            <a:schemeClr val="accent1"/>
+          </a:effectRef>
+          <a:fontRef idx="minor">
+            <a:schemeClr val="lt1"/>
+          </a:fontRef>
+        </p:style>
+        <p:txBody>
+          <a:bodyPr rtlCol="0" anchor="ctr" wrap="square"/>
+          <a:lstStyle/>
+          <a:p>
+            <a:pPr algn="ctr"/>
+            <a:r>
+              <a:rPr sz="1400" b="1">
+                <a:solidFill>
+                  <a:srgbClr val="0C1116"/>
+                </a:solidFill>
+                <a:latin typeface="Arial"/>
+              </a:rPr>
+              <a:t>2  The GPU runs it but the output is garbage</a:t>
+            </a:r>
+          </a:p>
+          <a:p>
+            <a:pPr algn="ctr"/>
+            <a:r>
+              <a:rPr sz="1200">
+                <a:solidFill>
+                  <a:srgbClr val="38424E"/>
+                </a:solidFill>
+                <a:latin typeface="Arial"/>
+              </a:rPr>
+              <a:t>PrismML's 1-bit Bonsai-8B: non-finite logits on Adreno, decoded at full speed</a:t>
+            </a:r>
+          </a:p>
+        </p:txBody>
+      </p:sp>
+      <p:sp>
+        <p:nvSpPr>
+          <p:cNvPr id="10" name="TextBox 9"/>
+          <p:cNvSpPr txBox="1"/>
+          <p:nvPr/>
+        </p:nvSpPr>
+        <p:spPr>
+          <a:xfrm>
+            <a:off x="7132320" y="4297680"/>
+            <a:ext cx="4572000" cy="457200"/>
+          </a:xfrm>
+          <a:prstGeom prst="rect">
+            <a:avLst/>
+          </a:prstGeom>
+          <a:noFill/>
+        </p:spPr>
+        <p:txBody>
+          <a:bodyPr wrap="square" anchor="t" lIns="36576" rIns="36576" tIns="18288" bIns="18288">
+            <a:spAutoFit/>
+          </a:bodyPr>
+          <a:lstStyle/>
+          <a:p>
+            <a:pPr algn="l">
+              <a:lnSpc>
+                <a:spcPct val="115000"/>
+              </a:lnSpc>
+            </a:pPr>
+            <a:r>
+              <a:rPr sz="1400" b="0">
+                <a:solidFill>
+                  <a:srgbClr val="38424E"/>
+                </a:solidFill>
+                <a:latin typeface="Arial"/>
+              </a:rPr>
+              <a:t>Every run is graded. A model that fails is marked, and the request re-runs on the CPU.</a:t>
+            </a:r>
+          </a:p>
+        </p:txBody>
+      </p:sp>
+      <p:sp>
+        <p:nvSpPr>
+          <p:cNvPr id="11" name="Rounded Rectangle 10"/>
+          <p:cNvSpPr/>
+          <p:nvPr/>
+        </p:nvSpPr>
+        <p:spPr>
+          <a:xfrm>
+            <a:off x="7132320" y="4937760"/>
+            <a:ext cx="4572000" cy="1005840"/>
+          </a:xfrm>
+          <a:prstGeom prst="roundRect">
+            <a:avLst>
+              <a:gd name="adj" fmla="val 6000"/>
+            </a:avLst>
+          </a:prstGeom>
+          <a:solidFill>
+            <a:srgbClr val="E4F3EC"/>
+          </a:solidFill>
+          <a:ln w="15875">
+            <a:solidFill>
+              <a:srgbClr val="1A7A58"/>
+            </a:solidFill>
+          </a:ln>
+          <a:effectLst/>
+        </p:spPr>
+        <p:style>
+          <a:lnRef idx="1">
+            <a:schemeClr val="accent1"/>
+          </a:lnRef>
+          <a:fillRef idx="3">
+            <a:schemeClr val="accent1"/>
+          </a:fillRef>
+          <a:effectRef idx="2">
+            <a:schemeClr val="accent1"/>
+          </a:effectRef>
+          <a:fontRef idx="minor">
+            <a:schemeClr val="lt1"/>
+          </a:fontRef>
+        </p:style>
+        <p:txBody>
+          <a:bodyPr rtlCol="0" anchor="ctr" wrap="square"/>
+          <a:lstStyle/>
+          <a:p>
+            <a:pPr algn="ctr"/>
+            <a:r>
+              <a:rPr sz="1400" b="1">
+                <a:solidFill>
+                  <a:srgbClr val="0C1116"/>
+                </a:solidFill>
+                <a:latin typeface="Arial"/>
+              </a:rPr>
+              <a:t>On the CPU one lever is left</a:t>
+            </a:r>
+          </a:p>
+          <a:p>
+            <a:pPr algn="ctr"/>
+            <a:r>
+              <a:rPr sz="1200">
+                <a:solidFill>
+                  <a:srgbClr val="38424E"/>
+                </a:solidFill>
+                <a:latin typeface="Arial"/>
+              </a:rPr>
+              <a:t>the clock saves nothing, K cannot drop below 1024, so the answer cap tiers alone</a:t>
+            </a:r>
+          </a:p>
+        </p:txBody>
+      </p:sp>
+      <p:graphicFrame>
+        <p:nvGraphicFramePr>
+          <p:cNvPr id="12" name="Table 11"/>
+          <p:cNvGraphicFramePr>
+            <a:graphicFrameLocks noGrp="1"/>
+          </p:cNvGraphicFramePr>
+          <p:nvPr/>
+        </p:nvGraphicFramePr>
+        <p:xfrm>
+          <a:off x="548640" y="4846320"/>
+          <a:ext cx="6309360" cy="1097280"/>
+        </p:xfrm>
+        <a:graphic>
+          <a:graphicData uri="http://schemas.openxmlformats.org/drawingml/2006/table">
+            <a:tbl>
+              <a:tblPr firstRow="1" bandRow="1">
+                <a:tableStyleId>{5C22544A-7EE6-4342-B048-85BDC9FD1C3A}</a:tableStyleId>
+              </a:tblPr>
+              <a:tblGrid>
+                <a:gridCol w="2468880"/>
+                <a:gridCol w="1280160"/>
+                <a:gridCol w="1280160"/>
+                <a:gridCol w="1280160"/>
+              </a:tblGrid>
+              <a:tr h="548640">
+                <a:tc>
+                  <a:txBody>
+                    <a:bodyPr wrap="square"/>
+                    <a:lstStyle/>
+                    <a:p>
+                      <a:r>
+                        <a:rPr sz="1300" b="1">
+                          <a:solidFill>
+                            <a:srgbClr val="0C1116"/>
+                          </a:solidFill>
+                          <a:latin typeface="Arial"/>
+                        </a:rPr>
+                        <a:t>Bonsai-8B on the CPU</a:t>
+                      </a:r>
+                    </a:p>
+                  </a:txBody>
+                  <a:tcPr marL="73152" marR="73152" marT="45720" marB="45720">
+                    <a:solidFill>
+                      <a:srgbClr val="EEF1F4"/>
+                    </a:solidFill>
+                  </a:tcPr>
+                </a:tc>
+                <a:tc>
+                  <a:txBody>
+                    <a:bodyPr wrap="square"/>
+                    <a:lstStyle/>
+                    <a:p>
+                      <a:r>
+                        <a:rPr sz="1300" b="1">
+                          <a:solidFill>
+                            <a:srgbClr val="0C1116"/>
+                          </a:solidFill>
+                          <a:latin typeface="Arial"/>
+                        </a:rPr>
+                        <a:t>cap 4096</a:t>
+                      </a:r>
+                    </a:p>
+                  </a:txBody>
+                  <a:tcPr marL="73152" marR="73152" marT="45720" marB="45720">
+                    <a:solidFill>
+                      <a:srgbClr val="EEF1F4"/>
+                    </a:solidFill>
+                  </a:tcPr>
+                </a:tc>
+                <a:tc>
+                  <a:txBody>
+                    <a:bodyPr wrap="square"/>
+                    <a:lstStyle/>
+                    <a:p>
+                      <a:r>
+                        <a:rPr sz="1300" b="1">
+                          <a:solidFill>
+                            <a:srgbClr val="0C1116"/>
+                          </a:solidFill>
+                          <a:latin typeface="Arial"/>
+                        </a:rPr>
+                        <a:t>cap 1024</a:t>
+                      </a:r>
+                    </a:p>
+                  </a:txBody>
+                  <a:tcPr marL="73152" marR="73152" marT="45720" marB="45720">
+                    <a:solidFill>
+                      <a:srgbClr val="EEF1F4"/>
+                    </a:solidFill>
+                  </a:tcPr>
+                </a:tc>
+                <a:tc>
+                  <a:txBody>
+                    <a:bodyPr wrap="square"/>
+                    <a:lstStyle/>
+                    <a:p>
+                      <a:r>
+                        <a:rPr sz="1300" b="1">
+                          <a:solidFill>
+                            <a:srgbClr val="0C1116"/>
+                          </a:solidFill>
+                          <a:latin typeface="Arial"/>
+                        </a:rPr>
+                        <a:t>cap 512</a:t>
+                      </a:r>
+                    </a:p>
+                  </a:txBody>
+                  <a:tcPr marL="73152" marR="73152" marT="45720" marB="45720">
+                    <a:solidFill>
+                      <a:srgbClr val="EEF1F4"/>
+                    </a:solidFill>
+                  </a:tcPr>
+                </a:tc>
+              </a:tr>
+              <a:tr h="548640">
+                <a:tc>
+                  <a:txBody>
+                    <a:bodyPr wrap="square"/>
+                    <a:lstStyle/>
+                    <a:p>
+                      <a:r>
+                        <a:rPr sz="1300">
+                          <a:solidFill>
+                            <a:srgbClr val="38424E"/>
+                          </a:solidFill>
+                          <a:latin typeface="Arial"/>
+                        </a:rPr>
+                        <a:t>measured per-token costs</a:t>
+                      </a:r>
+                    </a:p>
+                  </a:txBody>
+                  <a:tcPr marL="73152" marR="73152" marT="45720" marB="45720">
+                    <a:solidFill>
+                      <a:srgbClr val="FFFFFF"/>
+                    </a:solidFill>
+                  </a:tcPr>
+                </a:tc>
+                <a:tc>
+                  <a:txBody>
+                    <a:bodyPr wrap="square"/>
+                    <a:lstStyle/>
+                    <a:p>
+                      <a:r>
+                        <a:rPr sz="1300">
+                          <a:solidFill>
+                            <a:srgbClr val="38424E"/>
+                          </a:solidFill>
+                          <a:latin typeface="Arial"/>
+                        </a:rPr>
+                        <a:t>7853 J</a:t>
+                      </a:r>
+                    </a:p>
+                  </a:txBody>
+                  <a:tcPr marL="73152" marR="73152" marT="45720" marB="45720">
+                    <a:solidFill>
+                      <a:srgbClr val="FFFFFF"/>
+                    </a:solidFill>
+                  </a:tcPr>
+                </a:tc>
+                <a:tc>
+                  <a:txBody>
+                    <a:bodyPr wrap="square"/>
+                    <a:lstStyle/>
+                    <a:p>
+                      <a:r>
+                        <a:rPr sz="1300">
+                          <a:solidFill>
+                            <a:srgbClr val="38424E"/>
+                          </a:solidFill>
+                          <a:latin typeface="Arial"/>
+                        </a:rPr>
+                        <a:t>5310 J, -32%</a:t>
+                      </a:r>
+                    </a:p>
+                  </a:txBody>
+                  <a:tcPr marL="73152" marR="73152" marT="45720" marB="45720">
+                    <a:solidFill>
+                      <a:srgbClr val="FFFFFF"/>
+                    </a:solidFill>
+                  </a:tcPr>
+                </a:tc>
+                <a:tc>
+                  <a:txBody>
+                    <a:bodyPr wrap="square"/>
+                    <a:lstStyle/>
+                    <a:p>
+                      <a:r>
+                        <a:rPr sz="1300">
+                          <a:solidFill>
+                            <a:srgbClr val="38424E"/>
+                          </a:solidFill>
+                          <a:latin typeface="Arial"/>
+                        </a:rPr>
+                        <a:t>4886 J, -38%</a:t>
+                      </a:r>
+                    </a:p>
+                  </a:txBody>
+                  <a:tcPr marL="73152" marR="73152" marT="45720" marB="45720">
+                    <a:solidFill>
+                      <a:srgbClr val="FFFFFF"/>
+                    </a:solidFill>
+                  </a:tcPr>
+                </a:tc>
+              </a:tr>
+            </a:tbl>
+          </a:graphicData>
+        </a:graphic>
+      </p:graphicFrame>
+      <p:sp>
+        <p:nvSpPr>
+          <p:cNvPr id="13" name="TextBox 12"/>
+          <p:cNvSpPr txBox="1"/>
+          <p:nvPr/>
+        </p:nvSpPr>
+        <p:spPr>
+          <a:xfrm>
+            <a:off x="548640" y="6382512"/>
+            <a:ext cx="10424160" cy="365760"/>
+          </a:xfrm>
+          <a:prstGeom prst="rect">
+            <a:avLst/>
+          </a:prstGeom>
+          <a:noFill/>
+        </p:spPr>
+        <p:txBody>
+          <a:bodyPr wrap="square" anchor="t" lIns="36576" rIns="36576" tIns="18288" bIns="18288">
+            <a:spAutoFit/>
+          </a:bodyPr>
+          <a:lstStyle/>
+          <a:p>
+            <a:pPr algn="l">
+              <a:lnSpc>
+                <a:spcPct val="115000"/>
+              </a:lnSpc>
+            </a:pPr>
+            <a:r>
               <a:rPr sz="950" b="0">
                 <a:solidFill>
                   <a:srgbClr val="6B7785"/>
                 </a:solidFill>
                 <a:latin typeface="Arial"/>
               </a:rPr>
-              <a:t>Predicted from the measured cost table (ukv_sched_table, per-token costs) for this request; GPU_OK and HOT rules in ukv_sched.sh.</a:t>
+              <a:t>GPU and CPU plan costs predicted from the measured cost table. Bonsai figures from its own per-token costs, /tmp/nat_bonsai. Backend rules in ukv_sched.sh v2.5.</a:t>
             </a:r>
           </a:p>
         </p:txBody>

</xml_diff>